<commit_message>
feat(microservice): implement high-performance Golang engine and update pitch deck architecture
</commit_message>
<xml_diff>
--- a/PitchDeck_CareerStudentAI.pptx
+++ b/PitchDeck_CareerStudentAI.pptx
@@ -4538,7 +4538,7 @@
               </a:defRPr>
             </a:pPr>
             <a:r>
-              <a:t>Struktur Teknologi Modern Kelas Industri dengan Efisiensi Biaya Operasional Maksimal</a:t>
+              <a:t>Struktur Teknologi Modern Terdistribusi: Next.js 16, Microservices Golang gRPC, dan PWA Offline-First</a:t>
             </a:r>
           </a:p>
         </p:txBody>
@@ -4552,7 +4552,7 @@
         <p:spPr>
           <a:xfrm>
             <a:off x="731520" y="1463040"/>
-            <a:ext cx="10728655" cy="868680"/>
+            <a:ext cx="5242255" cy="1463040"/>
           </a:xfrm>
           <a:prstGeom prst="roundRect">
             <a:avLst/>
@@ -4596,8 +4596,8 @@
         </p:nvSpPr>
         <p:spPr>
           <a:xfrm>
-            <a:off x="914400" y="1645920"/>
-            <a:ext cx="2011680" cy="502920"/>
+            <a:off x="914400" y="1600200"/>
+            <a:ext cx="2560320" cy="320040"/>
           </a:xfrm>
           <a:prstGeom prst="roundRect">
             <a:avLst/>
@@ -4635,68 +4635,21 @@
               </a:defRPr>
             </a:pPr>
             <a:r>
-              <a:t>FRONTEND &amp; CORE ENGINE</a:t>
-            </a:r>
-          </a:p>
-        </p:txBody>
-      </p:sp>
-      <p:sp>
-        <p:nvSpPr>
-          <p:cNvPr id="7" name="TextBox 6"/>
-          <p:cNvSpPr txBox="1"/>
-          <p:nvPr/>
-        </p:nvSpPr>
-        <p:spPr>
-          <a:xfrm>
-            <a:off x="3063240" y="1572768"/>
-            <a:ext cx="6217920" cy="685800"/>
-          </a:xfrm>
-          <a:prstGeom prst="rect">
-            <a:avLst/>
-          </a:prstGeom>
-          <a:noFill/>
-        </p:spPr>
-        <p:txBody>
-          <a:bodyPr wrap="square" lIns="0" rIns="0" tIns="0" bIns="0">
-            <a:spAutoFit/>
-          </a:bodyPr>
-          <a:lstStyle/>
-          <a:p>
-            <a:pPr>
-              <a:defRPr sz="1200" b="1">
-                <a:solidFill>
-                  <a:srgbClr val="0F172A"/>
-                </a:solidFill>
-              </a:defRPr>
-            </a:pPr>
-            <a:r>
-              <a:t>Next.js 16 (React 19 App Router) + TypeScript</a:t>
-            </a:r>
-          </a:p>
-          <a:p>
-            <a:pPr>
-              <a:defRPr sz="950">
-                <a:solidFill>
-                  <a:srgbClr val="64748B"/>
-                </a:solidFill>
-              </a:defRPr>
-            </a:pPr>
-            <a:r>
-              <a:t>Server-side rendering super cepat, routing modular 15 rute, dan tipe data statis yang mencegah runtime error.</a:t>
-            </a:r>
-          </a:p>
-        </p:txBody>
-      </p:sp>
-      <p:sp>
-        <p:nvSpPr>
-          <p:cNvPr id="8" name="Rounded Rectangle 7"/>
-          <p:cNvSpPr/>
-          <p:nvPr/>
-        </p:nvSpPr>
-        <p:spPr>
-          <a:xfrm>
-            <a:off x="9418320" y="1737360"/>
-            <a:ext cx="1828800" cy="320040"/>
+              <a:t>FRONTEND &amp; APP ROUTER</a:t>
+            </a:r>
+          </a:p>
+        </p:txBody>
+      </p:sp>
+      <p:sp>
+        <p:nvSpPr>
+          <p:cNvPr id="7" name="Rounded Rectangle 6"/>
+          <p:cNvSpPr/>
+          <p:nvPr/>
+        </p:nvSpPr>
+        <p:spPr>
+          <a:xfrm>
+            <a:off x="4206240" y="1600200"/>
+            <a:ext cx="1554480" cy="320040"/>
           </a:xfrm>
           <a:prstGeom prst="roundRect">
             <a:avLst/>
@@ -4743,14 +4696,61 @@
       </p:sp>
       <p:sp>
         <p:nvSpPr>
+          <p:cNvPr id="8" name="TextBox 7"/>
+          <p:cNvSpPr txBox="1"/>
+          <p:nvPr/>
+        </p:nvSpPr>
+        <p:spPr>
+          <a:xfrm>
+            <a:off x="914400" y="1993392"/>
+            <a:ext cx="4876495" cy="868680"/>
+          </a:xfrm>
+          <a:prstGeom prst="rect">
+            <a:avLst/>
+          </a:prstGeom>
+          <a:noFill/>
+        </p:spPr>
+        <p:txBody>
+          <a:bodyPr wrap="square" lIns="0" rIns="0" tIns="0" bIns="0">
+            <a:spAutoFit/>
+          </a:bodyPr>
+          <a:lstStyle/>
+          <a:p>
+            <a:pPr>
+              <a:defRPr sz="1150" b="1">
+                <a:solidFill>
+                  <a:srgbClr val="0F172A"/>
+                </a:solidFill>
+              </a:defRPr>
+            </a:pPr>
+            <a:r>
+              <a:t>Next.js 16 (React 19) + TypeScript</a:t>
+            </a:r>
+          </a:p>
+          <a:p>
+            <a:pPr>
+              <a:defRPr sz="950">
+                <a:solidFill>
+                  <a:srgbClr val="64748B"/>
+                </a:solidFill>
+              </a:defRPr>
+            </a:pPr>
+            <a:r>
+              <a:t>Server-side rendering super cepat, routing modular 15 rute, dan type-safety penuh yang menjamin keandalan sistem.</a:t>
+            </a:r>
+          </a:p>
+        </p:txBody>
+      </p:sp>
+      <p:sp>
+        <p:nvSpPr>
           <p:cNvPr id="9" name="Rounded Rectangle 8"/>
           <p:cNvSpPr/>
           <p:nvPr/>
         </p:nvSpPr>
         <p:spPr>
           <a:xfrm>
-            <a:off x="731520" y="2423160"/>
-            <a:ext cx="10728655" cy="868680"/>
+            <a:off x="6217920" y="1463040"/>
+            <a:ext cx="5242255" cy="1463040"/>
           </a:xfrm>
           <a:prstGeom prst="roundRect">
             <a:avLst/>
@@ -4794,8 +4794,8 @@
         </p:nvSpPr>
         <p:spPr>
           <a:xfrm>
-            <a:off x="914400" y="2606040"/>
-            <a:ext cx="2011680" cy="502920"/>
+            <a:off x="6400800" y="1600200"/>
+            <a:ext cx="2560320" cy="320040"/>
           </a:xfrm>
           <a:prstGeom prst="roundRect">
             <a:avLst/>
@@ -4833,68 +4833,21 @@
               </a:defRPr>
             </a:pPr>
             <a:r>
-              <a:t>STYLING &amp; DESIGN SYSTEM</a:t>
-            </a:r>
-          </a:p>
-        </p:txBody>
-      </p:sp>
-      <p:sp>
-        <p:nvSpPr>
-          <p:cNvPr id="11" name="TextBox 10"/>
-          <p:cNvSpPr txBox="1"/>
-          <p:nvPr/>
-        </p:nvSpPr>
-        <p:spPr>
-          <a:xfrm>
-            <a:off x="3063240" y="2532888"/>
-            <a:ext cx="6217920" cy="685800"/>
-          </a:xfrm>
-          <a:prstGeom prst="rect">
-            <a:avLst/>
-          </a:prstGeom>
-          <a:noFill/>
-        </p:spPr>
-        <p:txBody>
-          <a:bodyPr wrap="square" lIns="0" rIns="0" tIns="0" bIns="0">
-            <a:spAutoFit/>
-          </a:bodyPr>
-          <a:lstStyle/>
-          <a:p>
-            <a:pPr>
-              <a:defRPr sz="1200" b="1">
-                <a:solidFill>
-                  <a:srgbClr val="0F172A"/>
-                </a:solidFill>
-              </a:defRPr>
-            </a:pPr>
-            <a:r>
-              <a:t>Tailwind CSS + Lucide React Icons</a:t>
-            </a:r>
-          </a:p>
-          <a:p>
-            <a:pPr>
-              <a:defRPr sz="950">
-                <a:solidFill>
-                  <a:srgbClr val="64748B"/>
-                </a:solidFill>
-              </a:defRPr>
-            </a:pPr>
-            <a:r>
-              <a:t>Sistem utilitas CSS modern yang sangat ringan, responsif mobile/desktop, dan konsisten dengan brand identity.</a:t>
-            </a:r>
-          </a:p>
-        </p:txBody>
-      </p:sp>
-      <p:sp>
-        <p:nvSpPr>
-          <p:cNvPr id="12" name="Rounded Rectangle 11"/>
-          <p:cNvSpPr/>
-          <p:nvPr/>
-        </p:nvSpPr>
-        <p:spPr>
-          <a:xfrm>
-            <a:off x="9418320" y="2697480"/>
-            <a:ext cx="1828800" cy="320040"/>
+              <a:t>HIGH-PERFORMANCE BACKEND</a:t>
+            </a:r>
+          </a:p>
+        </p:txBody>
+      </p:sp>
+      <p:sp>
+        <p:nvSpPr>
+          <p:cNvPr id="11" name="Rounded Rectangle 10"/>
+          <p:cNvSpPr/>
+          <p:nvPr/>
+        </p:nvSpPr>
+        <p:spPr>
+          <a:xfrm>
+            <a:off x="9692640" y="1600200"/>
+            <a:ext cx="1554480" cy="320040"/>
           </a:xfrm>
           <a:prstGeom prst="roundRect">
             <a:avLst/>
@@ -4934,7 +4887,54 @@
               </a:defRPr>
             </a:pPr>
             <a:r>
-              <a:t>Open Source ($0)</a:t>
+              <a:t>High Concurrency ($0)</a:t>
+            </a:r>
+          </a:p>
+        </p:txBody>
+      </p:sp>
+      <p:sp>
+        <p:nvSpPr>
+          <p:cNvPr id="12" name="TextBox 11"/>
+          <p:cNvSpPr txBox="1"/>
+          <p:nvPr/>
+        </p:nvSpPr>
+        <p:spPr>
+          <a:xfrm>
+            <a:off x="6400800" y="1993392"/>
+            <a:ext cx="4876495" cy="868680"/>
+          </a:xfrm>
+          <a:prstGeom prst="rect">
+            <a:avLst/>
+          </a:prstGeom>
+          <a:noFill/>
+        </p:spPr>
+        <p:txBody>
+          <a:bodyPr wrap="square" lIns="0" rIns="0" tIns="0" bIns="0">
+            <a:spAutoFit/>
+          </a:bodyPr>
+          <a:lstStyle/>
+          <a:p>
+            <a:pPr>
+              <a:defRPr sz="1150" b="1">
+                <a:solidFill>
+                  <a:srgbClr val="0F172A"/>
+                </a:solidFill>
+              </a:defRPr>
+            </a:pPr>
+            <a:r>
+              <a:t>Golang (gRPC-Go) &amp; Protobuf v3</a:t>
+            </a:r>
+          </a:p>
+          <a:p>
+            <a:pPr>
+              <a:defRPr sz="950">
+                <a:solidFill>
+                  <a:srgbClr val="64748B"/>
+                </a:solidFill>
+              </a:defRPr>
+            </a:pPr>
+            <a:r>
+              <a:t>Microservices engine performa tinggi untuk komputasi taksonomi skill WEF 2023 dan parsing skor ATS sub-milidetik.</a:t>
             </a:r>
           </a:p>
         </p:txBody>
@@ -4947,8 +4947,8 @@
         </p:nvSpPr>
         <p:spPr>
           <a:xfrm>
-            <a:off x="731520" y="3383280"/>
-            <a:ext cx="10728655" cy="868680"/>
+            <a:off x="731520" y="3063240"/>
+            <a:ext cx="5242255" cy="1463040"/>
           </a:xfrm>
           <a:prstGeom prst="roundRect">
             <a:avLst/>
@@ -4992,8 +4992,8 @@
         </p:nvSpPr>
         <p:spPr>
           <a:xfrm>
-            <a:off x="914400" y="3566160"/>
-            <a:ext cx="2011680" cy="502920"/>
+            <a:off x="914400" y="3200400"/>
+            <a:ext cx="2560320" cy="320040"/>
           </a:xfrm>
           <a:prstGeom prst="roundRect">
             <a:avLst/>
@@ -5031,68 +5031,21 @@
               </a:defRPr>
             </a:pPr>
             <a:r>
-              <a:t>PWA &amp; LOCAL STORAGE</a:t>
-            </a:r>
-          </a:p>
-        </p:txBody>
-      </p:sp>
-      <p:sp>
-        <p:nvSpPr>
-          <p:cNvPr id="15" name="TextBox 14"/>
-          <p:cNvSpPr txBox="1"/>
-          <p:nvPr/>
-        </p:nvSpPr>
-        <p:spPr>
-          <a:xfrm>
-            <a:off x="3063240" y="3493008"/>
-            <a:ext cx="6217920" cy="685800"/>
-          </a:xfrm>
-          <a:prstGeom prst="rect">
-            <a:avLst/>
-          </a:prstGeom>
-          <a:noFill/>
-        </p:spPr>
-        <p:txBody>
-          <a:bodyPr wrap="square" lIns="0" rIns="0" tIns="0" bIns="0">
-            <a:spAutoFit/>
-          </a:bodyPr>
-          <a:lstStyle/>
-          <a:p>
-            <a:pPr>
-              <a:defRPr sz="1200" b="1">
-                <a:solidFill>
-                  <a:srgbClr val="0F172A"/>
-                </a:solidFill>
-              </a:defRPr>
-            </a:pPr>
-            <a:r>
-              <a:t>Progressive Web Apps (Service Worker) + IndexedDB</a:t>
-            </a:r>
-          </a:p>
-          <a:p>
-            <a:pPr>
-              <a:defRPr sz="950">
-                <a:solidFill>
-                  <a:srgbClr val="64748B"/>
-                </a:solidFill>
-              </a:defRPr>
-            </a:pPr>
-            <a:r>
-              <a:t>Aplikasi dapat diinstal di homescreen HP/laptop, berjalan offline-first, dan data CV tersimpan privat di perangkat.</a:t>
-            </a:r>
-          </a:p>
-        </p:txBody>
-      </p:sp>
-      <p:sp>
-        <p:nvSpPr>
-          <p:cNvPr id="16" name="Rounded Rectangle 15"/>
-          <p:cNvSpPr/>
-          <p:nvPr/>
-        </p:nvSpPr>
-        <p:spPr>
-          <a:xfrm>
-            <a:off x="9418320" y="3657600"/>
-            <a:ext cx="1828800" cy="320040"/>
+              <a:t>OFFLINE &amp; LOCAL STORAGE</a:t>
+            </a:r>
+          </a:p>
+        </p:txBody>
+      </p:sp>
+      <p:sp>
+        <p:nvSpPr>
+          <p:cNvPr id="15" name="Rounded Rectangle 14"/>
+          <p:cNvSpPr/>
+          <p:nvPr/>
+        </p:nvSpPr>
+        <p:spPr>
+          <a:xfrm>
+            <a:off x="4206240" y="3200400"/>
+            <a:ext cx="1554480" cy="320040"/>
           </a:xfrm>
           <a:prstGeom prst="roundRect">
             <a:avLst/>
@@ -5132,7 +5085,54 @@
               </a:defRPr>
             </a:pPr>
             <a:r>
-              <a:t>Open Source ($0)</a:t>
+              <a:t>Client Storage ($0)</a:t>
+            </a:r>
+          </a:p>
+        </p:txBody>
+      </p:sp>
+      <p:sp>
+        <p:nvSpPr>
+          <p:cNvPr id="16" name="TextBox 15"/>
+          <p:cNvSpPr txBox="1"/>
+          <p:nvPr/>
+        </p:nvSpPr>
+        <p:spPr>
+          <a:xfrm>
+            <a:off x="914400" y="3593592"/>
+            <a:ext cx="4876495" cy="868680"/>
+          </a:xfrm>
+          <a:prstGeom prst="rect">
+            <a:avLst/>
+          </a:prstGeom>
+          <a:noFill/>
+        </p:spPr>
+        <p:txBody>
+          <a:bodyPr wrap="square" lIns="0" rIns="0" tIns="0" bIns="0">
+            <a:spAutoFit/>
+          </a:bodyPr>
+          <a:lstStyle/>
+          <a:p>
+            <a:pPr>
+              <a:defRPr sz="1150" b="1">
+                <a:solidFill>
+                  <a:srgbClr val="0F172A"/>
+                </a:solidFill>
+              </a:defRPr>
+            </a:pPr>
+            <a:r>
+              <a:t>Progressive Web Apps + IndexedDB</a:t>
+            </a:r>
+          </a:p>
+          <a:p>
+            <a:pPr>
+              <a:defRPr sz="950">
+                <a:solidFill>
+                  <a:srgbClr val="64748B"/>
+                </a:solidFill>
+              </a:defRPr>
+            </a:pPr>
+            <a:r>
+              <a:t>Dapat diinstal di smartphone/desktop, berjalan offline-first, dan data CV tersimpan privat di perangkat lokal pengguna.</a:t>
             </a:r>
           </a:p>
         </p:txBody>
@@ -5145,8 +5145,8 @@
         </p:nvSpPr>
         <p:spPr>
           <a:xfrm>
-            <a:off x="731520" y="4343400"/>
-            <a:ext cx="10728655" cy="868680"/>
+            <a:off x="6217920" y="3063240"/>
+            <a:ext cx="5242255" cy="1463040"/>
           </a:xfrm>
           <a:prstGeom prst="roundRect">
             <a:avLst/>
@@ -5190,8 +5190,8 @@
         </p:nvSpPr>
         <p:spPr>
           <a:xfrm>
-            <a:off x="914400" y="4526280"/>
-            <a:ext cx="2011680" cy="502920"/>
+            <a:off x="6400800" y="3200400"/>
+            <a:ext cx="2560320" cy="320040"/>
           </a:xfrm>
           <a:prstGeom prst="roundRect">
             <a:avLst/>
@@ -5229,68 +5229,21 @@
               </a:defRPr>
             </a:pPr>
             <a:r>
-              <a:t>KEAMANAN &amp; AUTENTIKASI</a:t>
-            </a:r>
-          </a:p>
-        </p:txBody>
-      </p:sp>
-      <p:sp>
-        <p:nvSpPr>
-          <p:cNvPr id="19" name="TextBox 18"/>
-          <p:cNvSpPr txBox="1"/>
-          <p:nvPr/>
-        </p:nvSpPr>
-        <p:spPr>
-          <a:xfrm>
-            <a:off x="3063240" y="4453128"/>
-            <a:ext cx="6217920" cy="685800"/>
-          </a:xfrm>
-          <a:prstGeom prst="rect">
-            <a:avLst/>
-          </a:prstGeom>
-          <a:noFill/>
-        </p:spPr>
-        <p:txBody>
-          <a:bodyPr wrap="square" lIns="0" rIns="0" tIns="0" bIns="0">
-            <a:spAutoFit/>
-          </a:bodyPr>
-          <a:lstStyle/>
-          <a:p>
-            <a:pPr>
-              <a:defRPr sz="1200" b="1">
-                <a:solidFill>
-                  <a:srgbClr val="0F172A"/>
-                </a:solidFill>
-              </a:defRPr>
-            </a:pPr>
-            <a:r>
-              <a:t>Scrypt Password Hashing + OWASP Headers</a:t>
-            </a:r>
-          </a:p>
-          <a:p>
-            <a:pPr>
-              <a:defRPr sz="950">
-                <a:solidFill>
-                  <a:srgbClr val="64748B"/>
-                </a:solidFill>
-              </a:defRPr>
-            </a:pPr>
-            <a:r>
-              <a:t>Salt 16-byte dengan verifikasi constant-time melawan timing attacks, proteksi CSRF, dan HTTP security headers.</a:t>
-            </a:r>
-          </a:p>
-        </p:txBody>
-      </p:sp>
-      <p:sp>
-        <p:nvSpPr>
-          <p:cNvPr id="20" name="Rounded Rectangle 19"/>
-          <p:cNvSpPr/>
-          <p:nvPr/>
-        </p:nvSpPr>
-        <p:spPr>
-          <a:xfrm>
-            <a:off x="9418320" y="4617720"/>
-            <a:ext cx="1828800" cy="320040"/>
+              <a:t>KEAMANAN &amp; ENKRIPSI</a:t>
+            </a:r>
+          </a:p>
+        </p:txBody>
+      </p:sp>
+      <p:sp>
+        <p:nvSpPr>
+          <p:cNvPr id="19" name="Rounded Rectangle 18"/>
+          <p:cNvSpPr/>
+          <p:nvPr/>
+        </p:nvSpPr>
+        <p:spPr>
+          <a:xfrm>
+            <a:off x="9692640" y="3200400"/>
+            <a:ext cx="1554480" cy="320040"/>
           </a:xfrm>
           <a:prstGeom prst="roundRect">
             <a:avLst/>
@@ -5337,14 +5290,61 @@
       </p:sp>
       <p:sp>
         <p:nvSpPr>
+          <p:cNvPr id="20" name="TextBox 19"/>
+          <p:cNvSpPr txBox="1"/>
+          <p:nvPr/>
+        </p:nvSpPr>
+        <p:spPr>
+          <a:xfrm>
+            <a:off x="6400800" y="3593592"/>
+            <a:ext cx="4876495" cy="868680"/>
+          </a:xfrm>
+          <a:prstGeom prst="rect">
+            <a:avLst/>
+          </a:prstGeom>
+          <a:noFill/>
+        </p:spPr>
+        <p:txBody>
+          <a:bodyPr wrap="square" lIns="0" rIns="0" tIns="0" bIns="0">
+            <a:spAutoFit/>
+          </a:bodyPr>
+          <a:lstStyle/>
+          <a:p>
+            <a:pPr>
+              <a:defRPr sz="1150" b="1">
+                <a:solidFill>
+                  <a:srgbClr val="0F172A"/>
+                </a:solidFill>
+              </a:defRPr>
+            </a:pPr>
+            <a:r>
+              <a:t>Scrypt Hashing &amp; OWASP Headers</a:t>
+            </a:r>
+          </a:p>
+          <a:p>
+            <a:pPr>
+              <a:defRPr sz="950">
+                <a:solidFill>
+                  <a:srgbClr val="64748B"/>
+                </a:solidFill>
+              </a:defRPr>
+            </a:pPr>
+            <a:r>
+              <a:t>Salt 16-byte dengan verifikasi constant-time melawan timing attacks, CSPRNG OTP, dan HTTP security headers ketat.</a:t>
+            </a:r>
+          </a:p>
+        </p:txBody>
+      </p:sp>
+      <p:sp>
+        <p:nvSpPr>
           <p:cNvPr id="21" name="Rounded Rectangle 20"/>
           <p:cNvSpPr/>
           <p:nvPr/>
         </p:nvSpPr>
         <p:spPr>
           <a:xfrm>
-            <a:off x="731520" y="5303520"/>
-            <a:ext cx="10728655" cy="868680"/>
+            <a:off x="731520" y="4663440"/>
+            <a:ext cx="5242255" cy="1463040"/>
           </a:xfrm>
           <a:prstGeom prst="roundRect">
             <a:avLst/>
@@ -5388,8 +5388,8 @@
         </p:nvSpPr>
         <p:spPr>
           <a:xfrm>
-            <a:off x="914400" y="5486400"/>
-            <a:ext cx="2011680" cy="502920"/>
+            <a:off x="914400" y="4800600"/>
+            <a:ext cx="2560320" cy="320040"/>
           </a:xfrm>
           <a:prstGeom prst="roundRect">
             <a:avLst/>
@@ -5427,68 +5427,21 @@
               </a:defRPr>
             </a:pPr>
             <a:r>
-              <a:t>HOSTING &amp; DEPLOYMENT</a:t>
-            </a:r>
-          </a:p>
-        </p:txBody>
-      </p:sp>
-      <p:sp>
-        <p:nvSpPr>
-          <p:cNvPr id="23" name="TextBox 22"/>
-          <p:cNvSpPr txBox="1"/>
-          <p:nvPr/>
-        </p:nvSpPr>
-        <p:spPr>
-          <a:xfrm>
-            <a:off x="3063240" y="5413248"/>
-            <a:ext cx="6217920" cy="685800"/>
-          </a:xfrm>
-          <a:prstGeom prst="rect">
-            <a:avLst/>
-          </a:prstGeom>
-          <a:noFill/>
-        </p:spPr>
-        <p:txBody>
-          <a:bodyPr wrap="square" lIns="0" rIns="0" tIns="0" bIns="0">
-            <a:spAutoFit/>
-          </a:bodyPr>
-          <a:lstStyle/>
-          <a:p>
-            <a:pPr>
-              <a:defRPr sz="1200" b="1">
-                <a:solidFill>
-                  <a:srgbClr val="0F172A"/>
-                </a:solidFill>
-              </a:defRPr>
-            </a:pPr>
-            <a:r>
-              <a:t>Vercel Serverless Edge Cloud</a:t>
-            </a:r>
-          </a:p>
-          <a:p>
-            <a:pPr>
-              <a:defRPr sz="950">
-                <a:solidFill>
-                  <a:srgbClr val="64748B"/>
-                </a:solidFill>
-              </a:defRPr>
-            </a:pPr>
-            <a:r>
-              <a:t>Infrastruktur serverless global dengan otomatisasi CI/CD dari repositori GitHub, high availability 99.9%.</a:t>
-            </a:r>
-          </a:p>
-        </p:txBody>
-      </p:sp>
-      <p:sp>
-        <p:nvSpPr>
-          <p:cNvPr id="24" name="Rounded Rectangle 23"/>
-          <p:cNvSpPr/>
-          <p:nvPr/>
-        </p:nvSpPr>
-        <p:spPr>
-          <a:xfrm>
-            <a:off x="9418320" y="5577840"/>
-            <a:ext cx="1828800" cy="320040"/>
+              <a:t>CLOUD &amp; SERVERLESS HOSTING</a:t>
+            </a:r>
+          </a:p>
+        </p:txBody>
+      </p:sp>
+      <p:sp>
+        <p:nvSpPr>
+          <p:cNvPr id="23" name="Rounded Rectangle 22"/>
+          <p:cNvSpPr/>
+          <p:nvPr/>
+        </p:nvSpPr>
+        <p:spPr>
+          <a:xfrm>
+            <a:off x="4206240" y="4800600"/>
+            <a:ext cx="1554480" cy="320040"/>
           </a:xfrm>
           <a:prstGeom prst="roundRect">
             <a:avLst/>
@@ -5528,14 +5481,259 @@
               </a:defRPr>
             </a:pPr>
             <a:r>
-              <a:t>Free Tier Production ($0)</a:t>
-            </a:r>
-          </a:p>
-        </p:txBody>
-      </p:sp>
-      <p:sp>
-        <p:nvSpPr>
-          <p:cNvPr id="25" name="Rectangle 24"/>
+              <a:t>Free Tier Live ($0)</a:t>
+            </a:r>
+          </a:p>
+        </p:txBody>
+      </p:sp>
+      <p:sp>
+        <p:nvSpPr>
+          <p:cNvPr id="24" name="TextBox 23"/>
+          <p:cNvSpPr txBox="1"/>
+          <p:nvPr/>
+        </p:nvSpPr>
+        <p:spPr>
+          <a:xfrm>
+            <a:off x="914400" y="5193792"/>
+            <a:ext cx="4876495" cy="868680"/>
+          </a:xfrm>
+          <a:prstGeom prst="rect">
+            <a:avLst/>
+          </a:prstGeom>
+          <a:noFill/>
+        </p:spPr>
+        <p:txBody>
+          <a:bodyPr wrap="square" lIns="0" rIns="0" tIns="0" bIns="0">
+            <a:spAutoFit/>
+          </a:bodyPr>
+          <a:lstStyle/>
+          <a:p>
+            <a:pPr>
+              <a:defRPr sz="1150" b="1">
+                <a:solidFill>
+                  <a:srgbClr val="0F172A"/>
+                </a:solidFill>
+              </a:defRPr>
+            </a:pPr>
+            <a:r>
+              <a:t>Vercel Serverless Edge Platform</a:t>
+            </a:r>
+          </a:p>
+          <a:p>
+            <a:pPr>
+              <a:defRPr sz="950">
+                <a:solidFill>
+                  <a:srgbClr val="64748B"/>
+                </a:solidFill>
+              </a:defRPr>
+            </a:pPr>
+            <a:r>
+              <a:t>Infrastruktur cloud global dengan otomatisasi CI/CD dari repositori GitHub, high availability 99.9% tanpa cold start.</a:t>
+            </a:r>
+          </a:p>
+        </p:txBody>
+      </p:sp>
+      <p:sp>
+        <p:nvSpPr>
+          <p:cNvPr id="25" name="Rounded Rectangle 24"/>
+          <p:cNvSpPr/>
+          <p:nvPr/>
+        </p:nvSpPr>
+        <p:spPr>
+          <a:xfrm>
+            <a:off x="6217920" y="4663440"/>
+            <a:ext cx="5242255" cy="1463040"/>
+          </a:xfrm>
+          <a:prstGeom prst="roundRect">
+            <a:avLst/>
+          </a:prstGeom>
+          <a:solidFill>
+            <a:srgbClr val="FFFFFF"/>
+          </a:solidFill>
+          <a:ln w="12700">
+            <a:solidFill>
+              <a:srgbClr val="E2E8F0"/>
+            </a:solidFill>
+          </a:ln>
+        </p:spPr>
+        <p:style>
+          <a:lnRef idx="1">
+            <a:schemeClr val="accent1"/>
+          </a:lnRef>
+          <a:fillRef idx="3">
+            <a:schemeClr val="accent1"/>
+          </a:fillRef>
+          <a:effectRef idx="2">
+            <a:schemeClr val="accent1"/>
+          </a:effectRef>
+          <a:fontRef idx="minor">
+            <a:schemeClr val="lt1"/>
+          </a:fontRef>
+        </p:style>
+        <p:txBody>
+          <a:bodyPr rtlCol="0" anchor="ctr"/>
+          <a:lstStyle/>
+          <a:p>
+            <a:pPr algn="ctr"/>
+          </a:p>
+        </p:txBody>
+      </p:sp>
+      <p:sp>
+        <p:nvSpPr>
+          <p:cNvPr id="26" name="Rounded Rectangle 25"/>
+          <p:cNvSpPr/>
+          <p:nvPr/>
+        </p:nvSpPr>
+        <p:spPr>
+          <a:xfrm>
+            <a:off x="6400800" y="4800600"/>
+            <a:ext cx="2560320" cy="320040"/>
+          </a:xfrm>
+          <a:prstGeom prst="roundRect">
+            <a:avLst/>
+          </a:prstGeom>
+          <a:solidFill>
+            <a:srgbClr val="0F172A"/>
+          </a:solidFill>
+          <a:ln>
+            <a:noFill/>
+          </a:ln>
+        </p:spPr>
+        <p:style>
+          <a:lnRef idx="1">
+            <a:schemeClr val="accent1"/>
+          </a:lnRef>
+          <a:fillRef idx="3">
+            <a:schemeClr val="accent1"/>
+          </a:fillRef>
+          <a:effectRef idx="2">
+            <a:schemeClr val="accent1"/>
+          </a:effectRef>
+          <a:fontRef idx="minor">
+            <a:schemeClr val="lt1"/>
+          </a:fontRef>
+        </p:style>
+        <p:txBody>
+          <a:bodyPr rtlCol="0" anchor="ctr"/>
+          <a:lstStyle/>
+          <a:p>
+            <a:pPr algn="ctr">
+              <a:defRPr sz="850" b="1">
+                <a:solidFill>
+                  <a:srgbClr val="FFFFFF"/>
+                </a:solidFill>
+              </a:defRPr>
+            </a:pPr>
+            <a:r>
+              <a:t>ORM &amp; DATA PERSISTENCE</a:t>
+            </a:r>
+          </a:p>
+        </p:txBody>
+      </p:sp>
+      <p:sp>
+        <p:nvSpPr>
+          <p:cNvPr id="27" name="Rounded Rectangle 26"/>
+          <p:cNvSpPr/>
+          <p:nvPr/>
+        </p:nvSpPr>
+        <p:spPr>
+          <a:xfrm>
+            <a:off x="9692640" y="4800600"/>
+            <a:ext cx="1554480" cy="320040"/>
+          </a:xfrm>
+          <a:prstGeom prst="roundRect">
+            <a:avLst/>
+          </a:prstGeom>
+          <a:solidFill>
+            <a:srgbClr val="EAF4F4"/>
+          </a:solidFill>
+          <a:ln w="12700">
+            <a:solidFill>
+              <a:srgbClr val="00A6A6"/>
+            </a:solidFill>
+          </a:ln>
+        </p:spPr>
+        <p:style>
+          <a:lnRef idx="1">
+            <a:schemeClr val="accent1"/>
+          </a:lnRef>
+          <a:fillRef idx="3">
+            <a:schemeClr val="accent1"/>
+          </a:fillRef>
+          <a:effectRef idx="2">
+            <a:schemeClr val="accent1"/>
+          </a:effectRef>
+          <a:fontRef idx="minor">
+            <a:schemeClr val="lt1"/>
+          </a:fontRef>
+        </p:style>
+        <p:txBody>
+          <a:bodyPr rtlCol="0" anchor="ctr"/>
+          <a:lstStyle/>
+          <a:p>
+            <a:pPr algn="ctr">
+              <a:defRPr sz="850" b="1">
+                <a:solidFill>
+                  <a:srgbClr val="17324D"/>
+                </a:solidFill>
+              </a:defRPr>
+            </a:pPr>
+            <a:r>
+              <a:t>Scalable DB ($0)</a:t>
+            </a:r>
+          </a:p>
+        </p:txBody>
+      </p:sp>
+      <p:sp>
+        <p:nvSpPr>
+          <p:cNvPr id="28" name="TextBox 27"/>
+          <p:cNvSpPr txBox="1"/>
+          <p:nvPr/>
+        </p:nvSpPr>
+        <p:spPr>
+          <a:xfrm>
+            <a:off x="6400800" y="5193792"/>
+            <a:ext cx="4876495" cy="868680"/>
+          </a:xfrm>
+          <a:prstGeom prst="rect">
+            <a:avLst/>
+          </a:prstGeom>
+          <a:noFill/>
+        </p:spPr>
+        <p:txBody>
+          <a:bodyPr wrap="square" lIns="0" rIns="0" tIns="0" bIns="0">
+            <a:spAutoFit/>
+          </a:bodyPr>
+          <a:lstStyle/>
+          <a:p>
+            <a:pPr>
+              <a:defRPr sz="1150" b="1">
+                <a:solidFill>
+                  <a:srgbClr val="0F172A"/>
+                </a:solidFill>
+              </a:defRPr>
+            </a:pPr>
+            <a:r>
+              <a:t>Prisma ORM &amp; PostgreSQL / SQLite</a:t>
+            </a:r>
+          </a:p>
+          <a:p>
+            <a:pPr>
+              <a:defRPr sz="950">
+                <a:solidFill>
+                  <a:srgbClr val="64748B"/>
+                </a:solidFill>
+              </a:defRPr>
+            </a:pPr>
+            <a:r>
+              <a:t>Manajemen skema database terstruktur dengan migrasi aman, mendukung transisi fleksibel lokal ke enterprise cloud.</a:t>
+            </a:r>
+          </a:p>
+        </p:txBody>
+      </p:sp>
+      <p:sp>
+        <p:nvSpPr>
+          <p:cNvPr id="29" name="Rectangle 28"/>
           <p:cNvSpPr/>
           <p:nvPr/>
         </p:nvSpPr>
@@ -5578,7 +5776,7 @@
       </p:sp>
       <p:sp>
         <p:nvSpPr>
-          <p:cNvPr id="26" name="TextBox 25"/>
+          <p:cNvPr id="30" name="TextBox 29"/>
           <p:cNvSpPr txBox="1"/>
           <p:nvPr/>
         </p:nvSpPr>
@@ -5613,7 +5811,7 @@
       </p:sp>
       <p:sp>
         <p:nvSpPr>
-          <p:cNvPr id="27" name="TextBox 26"/>
+          <p:cNvPr id="31" name="TextBox 30"/>
           <p:cNvSpPr txBox="1"/>
           <p:nvPr/>
         </p:nvSpPr>
@@ -6680,7 +6878,7 @@
               </a:defRPr>
             </a:pPr>
             <a:r>
-              <a:t>Aplikasi berbasis Progressive Web App (PWA) berjalan lancar di smartphone Android, iOS, maupun laptop tanpa perlu instalasi rumit dari app store.</a:t>
+              <a:t>   Aplikasi berbasis Progressive Web App (PWA) berjalan lancar di smartphone Android, iOS, maupun laptop tanpa perlu instalasi rumit dari app store.</a:t>
             </a:r>
           </a:p>
         </p:txBody>
@@ -6836,7 +7034,7 @@
               </a:defRPr>
             </a:pPr>
             <a:r>
-              <a:t>Teknologi modern Next.js 16, TypeScript, dan Tailwind CSS memastikan arsitektur sangat modular, cepat, aman, dan mudah dikembangkan lebih lanjut.</a:t>
+              <a:t>   Teknologi modern Next.js 16, TypeScript, Golang microservice, dan Tailwind CSS memastikan arsitektur sangat modular, cepat, dan aman.</a:t>
             </a:r>
           </a:p>
         </p:txBody>
@@ -6992,7 +7190,7 @@
               </a:defRPr>
             </a:pPr>
             <a:r>
-              <a:t>Seluruh fase rekayasa dari perancangan kognitif, coding, security hardening, hingga uji coba 42 black-box test selesai tepat waktu sesuai deadline kompetisi.</a:t>
+              <a:t>   Seluruh fase rekayasa dari perancangan kognitif, coding, security hardening, hingga uji coba 42 black-box test selesai tepat waktu sesuai deadline kompetisi.</a:t>
             </a:r>
           </a:p>
         </p:txBody>
@@ -7148,7 +7346,7 @@
               </a:defRPr>
             </a:pPr>
             <a:r>
-              <a:t>Menjadi solusi pertama yang secara tegas melarang otomatisasi buta AI melalui Explicit Approval Gate, dengan biaya operasional hosting $0 via Vercel.</a:t>
+              <a:t>   Menjadi solusi pertama yang secara tegas melarang otomatisasi buta AI melalui Explicit Approval Gate, dengan biaya operasional hosting $0 via Vercel.</a:t>
             </a:r>
           </a:p>
         </p:txBody>
@@ -8642,6 +8840,18 @@
               </a:defRPr>
             </a:pPr>
             <a:r>
+              <a:t>✓ High-Performance Microservices (Golang gRPC)</a:t>
+            </a:r>
+          </a:p>
+          <a:p>
+            <a:pPr>
+              <a:defRPr sz="950">
+                <a:solidFill>
+                  <a:srgbClr val="0F172A"/>
+                </a:solidFill>
+              </a:defRPr>
+            </a:pPr>
+            <a:r>
               <a:t>✓ Socratic Dialogue &amp; LLM Prompt Engineering</a:t>
             </a:r>
           </a:p>
@@ -8655,18 +8865,6 @@
             </a:pPr>
             <a:r>
               <a:t>✓ Security Hardening (Scrypt &amp; OWASP Compliance)</a:t>
-            </a:r>
-          </a:p>
-          <a:p>
-            <a:pPr>
-              <a:defRPr sz="950">
-                <a:solidFill>
-                  <a:srgbClr val="0F172A"/>
-                </a:solidFill>
-              </a:defRPr>
-            </a:pPr>
-            <a:r>
-              <a:t>✓ System Deployment &amp; CI/CD on Vercel</a:t>
             </a:r>
           </a:p>
         </p:txBody>
@@ -15300,7 +15498,7 @@
                   <a:srgbClr val="0F172A"/>
                 </a:solidFill>
               </a:rPr>
-              <a:t>Integrasi Audio-Visual Web Speech API — </a:t>
+              <a:t>Desain Microservices Engine (Golang gRPC) — </a:t>
             </a:r>
             <a:r>
               <a:rPr sz="1000">
@@ -15308,7 +15506,7 @@
                   <a:srgbClr val="64748B"/>
                 </a:solidFill>
               </a:rPr>
-              <a:t>Menerapkan speech recognition dan synthesis peramban untuk simulasi mock interview berbasis suara interaktif.</a:t>
+              <a:t>Merancang kontrak service komputasi taksonomi skill &amp; kalkulasi ATS berkecepatan tinggi.</a:t>
             </a:r>
           </a:p>
         </p:txBody>

</xml_diff>

<commit_message>
docs: fix pitch deck - correct app screenshots, add dosen pembimbing, add MOD-04 career discovery, universal scope
</commit_message>
<xml_diff>
--- a/PitchDeck_CareerStudentAI.pptx
+++ b/PitchDeck_CareerStudentAI.pptx
@@ -3222,14 +3222,14 @@
           <a:lstStyle/>
           <a:p>
             <a:pPr algn="ctr">
-              <a:defRPr sz="1100" b="1">
+              <a:defRPr sz="1000" b="1">
                 <a:solidFill>
                   <a:srgbClr val="00A6A6"/>
                 </a:solidFill>
               </a:defRPr>
             </a:pPr>
             <a:r>
-              <a:t>GDI FEST 2026  |  LOMBA INOVASI DIGITAL</a:t>
+              <a:t>GDI FEST 2026  |  LOMBA INOVASI DIGITAL  |  UNIVERSITAS TEKNOKRAT INDONESIA</a:t>
             </a:r>
           </a:p>
         </p:txBody>
@@ -3264,7 +3264,7 @@
               </a:defRPr>
             </a:pPr>
             <a:r>
-              <a:t>PITCH DECK INOVASI PENDIDIKAN &amp; TEKNOLOGI (3-MIN PITCH)</a:t>
+              <a:t>PITCH DECK — 3-MINUTE PRESENTATION</a:t>
             </a:r>
           </a:p>
           <a:p>
@@ -3370,8 +3370,8 @@
         </p:nvSpPr>
         <p:spPr>
           <a:xfrm>
-            <a:off x="731520" y="3840480"/>
-            <a:ext cx="10728655" cy="2103120"/>
+            <a:off x="731520" y="3794760"/>
+            <a:ext cx="10728655" cy="2331720"/>
           </a:xfrm>
           <a:prstGeom prst="roundRect">
             <a:avLst/>
@@ -3423,7 +3423,30 @@
               </a:defRPr>
             </a:pPr>
             <a:r>
-              <a:t>• Riki Ardiansyah (Ketua / Lead Architect - 24313003)    • Jovan Akbar Setiodono (UI/UX Specialist - 24313024)    • Fiqi Rahman Al Afkhoni (AI/QA Engineer - 24313023)</a:t>
+              <a:t>• Riki Ardiansyah (Ketua / Lead Architect — 24313003)    • Jovan Akbar Setiodono (UI/UX Specialist — 24313024)    • Fiqi Rahman Al Afkhoni (AI/QA Engineer — 24313023)</a:t>
+            </a:r>
+          </a:p>
+          <a:p>
+            <a:pPr>
+              <a:defRPr sz="400"/>
+            </a:pPr>
+          </a:p>
+          <a:p>
+            <a:r>
+              <a:rPr sz="1100" b="1">
+                <a:solidFill>
+                  <a:srgbClr val="F59E0B"/>
+                </a:solidFill>
+              </a:rPr>
+              <a:t>Dosen Pembimbing : </a:t>
+            </a:r>
+            <a:r>
+              <a:rPr sz="1100">
+                <a:solidFill>
+                  <a:srgbClr val="CBD5E1"/>
+                </a:solidFill>
+              </a:rPr>
+              <a:t>Dr. Erliyan Redy Susanto, M.Kom. (NIDN: 0211078201)</a:t>
             </a:r>
           </a:p>
           <a:p>
@@ -3447,7 +3470,7 @@
               </a:defRPr>
             </a:pPr>
             <a:r>
-              <a:t>Inovasi: Platform Universal untuk Seluruh Program Studi (Saintek, Soshum, Bisnis, Seni/Desain, &amp; Vokasi) • Live: career-student-ai.vercel.app</a:t>
+              <a:t>Platform Universal untuk Seluruh Program Studi &amp; Rumpun Keilmuan • Live: career-student-ai.vercel.app</a:t>
             </a:r>
           </a:p>
         </p:txBody>
@@ -3776,14 +3799,14 @@
           <a:lstStyle/>
           <a:p>
             <a:pPr algn="ctr">
-              <a:defRPr sz="1100" b="1">
+              <a:defRPr sz="1050" b="1">
                 <a:solidFill>
                   <a:srgbClr val="991B1B"/>
                 </a:solidFill>
               </a:defRPr>
             </a:pPr>
             <a:r>
-              <a:t>Paradoks Generative AI (ChatGPT/LLM Publik):</a:t>
+              <a:t>Paradoks Generative AI: Mahasiswa menggunakan LLM publik (ChatGPT/AI) → CV terlihat impresif, namun tanpa pemahaman mendalam.</a:t>
             </a:r>
           </a:p>
           <a:p>
@@ -3795,7 +3818,7 @@
               </a:defRPr>
             </a:pPr>
             <a:r>
-              <a:t>Mahasiswa mengandalkan otomasi copy-paste instan tanpa proses berpikir mendalam. Akibatnya, CV terlihat impresif tetapi kandidat kehilangan penguasaan narasi (cognitive atrophy) dan gagal saat diuji pewawancara.</a:t>
+              <a:t>Ketergantungan otomasi copy-paste pasif → Hilangnya daya nalar kritis (cognitive atrophy) → Kegagalan massal di wawancara mendalam.</a:t>
             </a:r>
           </a:p>
         </p:txBody>
@@ -3939,7 +3962,7 @@
               </a:defRPr>
             </a:pPr>
             <a:r>
-              <a:t>Mahasiswa menyalin teks buatan AI mentah-mentah ke dalam resume tanpa memahami logika dan metodologi di balik klaim pencapaian tersebut.</a:t>
+              <a:t>Mahasiswa menyalin konten buatan AI mentah-mentah ke resume tanpa memahami metodologi dan logika di balik klaim pencapaian tersebut.</a:t>
             </a:r>
           </a:p>
           <a:p>
@@ -4083,7 +4106,7 @@
               </a:defRPr>
             </a:pPr>
             <a:r>
-              <a:t>Interview Freeze di Depan Recruiter</a:t>
+              <a:t>Interview Freeze di Hadapan Recruiter</a:t>
             </a:r>
           </a:p>
           <a:p>
@@ -4095,7 +4118,7 @@
               </a:defRPr>
             </a:pPr>
             <a:r>
-              <a:t>Kandidat panik dan gagal menjawab pertanyaan studi kasus mendalam karena resume mereka dibuat oleh AI tanpa proses perenungan mandiri.</a:t>
+              <a:t>Kandidat panik dan gagal menjawab pertanyaan studi kasus mendalam. Resume dibuat oleh AI, bukan oleh pemikiran kandidat sendiri.</a:t>
             </a:r>
           </a:p>
           <a:p>
@@ -4239,7 +4262,7 @@
               </a:defRPr>
             </a:pPr>
             <a:r>
-              <a:t>Kesenjangan Kompetensi Lintas Jurusan</a:t>
+              <a:t>Blind Skill Gap lintas Program Studi</a:t>
             </a:r>
           </a:p>
           <a:p>
@@ -4251,7 +4274,7 @@
               </a:defRPr>
             </a:pPr>
             <a:r>
-              <a:t>Mahasiswa dari berbagai fakultas tidak tahu secara objektif apa saja gap hard skill &amp; soft skill mereka terhadap kebutuhan industri global (WEF 2023).</a:t>
+              <a:t>Mahasiswa dari berbagai jurusan tidak tahu secara objektif hard skill &amp; soft skill apa yang masih kurang terhadap standar industri global WEF 2023.</a:t>
             </a:r>
           </a:p>
           <a:p>
@@ -4533,7 +4556,7 @@
               </a:defRPr>
             </a:pPr>
             <a:r>
-              <a:t>Solusi: CareerStudent AI — 4 Modul Kognitif Universal</a:t>
+              <a:t>Solusi: CareerStudent AI — 4 Pilar Kognitif Universal</a:t>
             </a:r>
           </a:p>
           <a:p>
@@ -4545,7 +4568,7 @@
               </a:defRPr>
             </a:pPr>
             <a:r>
-              <a:t>Bukan Sekadar Resume Builder, Melainkan Adaptive Co-Pilot untuk Seluruh Program Studi</a:t>
+              <a:t>Bukan Sekadar CV Builder. Ini adalah Adaptive Co-Pilot untuk Seluruh Program Studi dan Rumpun Keilmuan.</a:t>
             </a:r>
           </a:p>
         </p:txBody>
@@ -4559,7 +4582,7 @@
         <p:spPr>
           <a:xfrm>
             <a:off x="731520" y="1463040"/>
-            <a:ext cx="5242255" cy="2194560"/>
+            <a:ext cx="5242255" cy="2286000"/>
           </a:xfrm>
           <a:prstGeom prst="roundRect">
             <a:avLst/>
@@ -4709,8 +4732,8 @@
         </p:nvSpPr>
         <p:spPr>
           <a:xfrm>
-            <a:off x="914400" y="2103120"/>
-            <a:ext cx="4876495" cy="1417320"/>
+            <a:off x="914400" y="2121408"/>
+            <a:ext cx="4876495" cy="1508760"/>
           </a:xfrm>
           <a:prstGeom prst="rect">
             <a:avLst/>
@@ -4724,38 +4747,38 @@
           <a:lstStyle/>
           <a:p>
             <a:pPr>
-              <a:defRPr sz="1300" b="1">
+              <a:defRPr sz="1250" b="1">
                 <a:solidFill>
                   <a:srgbClr val="0F172A"/>
                 </a:solidFill>
               </a:defRPr>
             </a:pPr>
             <a:r>
-              <a:t>Universal ATS Fast CV Builder</a:t>
+              <a:t>Universal ATS-Compliant Fast CV Builder</a:t>
             </a:r>
           </a:p>
           <a:p>
             <a:pPr>
-              <a:defRPr sz="950" b="1">
+              <a:defRPr sz="900" b="1">
                 <a:solidFill>
                   <a:srgbClr val="00A6A6"/>
                 </a:solidFill>
               </a:defRPr>
             </a:pPr>
             <a:r>
-              <a:t>Adaptif untuk Seluruh Program Studi</a:t>
+              <a:t>Adaptif untuk Seluruh Program Studi &amp; Rumpun Keilmuan</a:t>
             </a:r>
           </a:p>
           <a:p>
             <a:pPr>
-              <a:defRPr sz="950">
+              <a:defRPr sz="900">
                 <a:solidFill>
                   <a:srgbClr val="64748B"/>
                 </a:solidFill>
               </a:defRPr>
             </a:pPr>
             <a:r>
-              <a:t>Generator resume standar ATS internasional yang mendukung seluruh rumpun ilmu (Saintek, Soshum, Bisnis, Desain, &amp; Vokasi). Pembuatan CV siap kerja dalam waktu &lt; 5 menit.</a:t>
+              <a:t>Generator resume berstandar ATS internasional yang mendukung seluruh jurusan (Saintek, Soshum, Bisnis, Desain Kreatif, dan Vokasi) dengan pustaka kompetensi fleksibel. Siap kerja dalam &lt; 5 menit.</a:t>
             </a:r>
           </a:p>
         </p:txBody>
@@ -4769,7 +4792,7 @@
         <p:spPr>
           <a:xfrm>
             <a:off x="6217920" y="1463040"/>
-            <a:ext cx="5242255" cy="2194560"/>
+            <a:ext cx="5242255" cy="2286000"/>
           </a:xfrm>
           <a:prstGeom prst="roundRect">
             <a:avLst/>
@@ -4919,8 +4942,8 @@
         </p:nvSpPr>
         <p:spPr>
           <a:xfrm>
-            <a:off x="6400800" y="2103120"/>
-            <a:ext cx="4876495" cy="1417320"/>
+            <a:off x="6400800" y="2121408"/>
+            <a:ext cx="4876495" cy="1508760"/>
           </a:xfrm>
           <a:prstGeom prst="rect">
             <a:avLst/>
@@ -4934,7 +4957,7 @@
           <a:lstStyle/>
           <a:p>
             <a:pPr>
-              <a:defRPr sz="1300" b="1">
+              <a:defRPr sz="1250" b="1">
                 <a:solidFill>
                   <a:srgbClr val="0F172A"/>
                 </a:solidFill>
@@ -4946,7 +4969,7 @@
           </a:p>
           <a:p>
             <a:pPr>
-              <a:defRPr sz="950" b="1">
+              <a:defRPr sz="900" b="1">
                 <a:solidFill>
                   <a:srgbClr val="17324D"/>
                 </a:solidFill>
@@ -4958,14 +4981,14 @@
           </a:p>
           <a:p>
             <a:pPr>
-              <a:defRPr sz="950">
+              <a:defRPr sz="900">
                 <a:solidFill>
                   <a:srgbClr val="64748B"/>
                 </a:solidFill>
               </a:defRPr>
             </a:pPr>
             <a:r>
-              <a:t>Mekanisme pengaman pedagogis yang melarang AI menulis atau menyunting CV secara otomatis tanpa peninjauan, persetujuan eksplisit, dan pemahaman sadar pengguna.</a:t>
+              <a:t>AI dilarang menulis atau menyunting resume secara otomatis tanpa peninjauan dan persetujuan eksplisit dari pengguna. Kandidat wajib paham setiap kalimat di CV-nya sendiri.</a:t>
             </a:r>
           </a:p>
         </p:txBody>
@@ -4978,8 +5001,8 @@
         </p:nvSpPr>
         <p:spPr>
           <a:xfrm>
-            <a:off x="731520" y="3840480"/>
-            <a:ext cx="5242255" cy="2194560"/>
+            <a:off x="731520" y="3931920"/>
+            <a:ext cx="5242255" cy="2286000"/>
           </a:xfrm>
           <a:prstGeom prst="roundRect">
             <a:avLst/>
@@ -5023,7 +5046,7 @@
         </p:nvSpPr>
         <p:spPr>
           <a:xfrm>
-            <a:off x="914400" y="4023360"/>
+            <a:off x="914400" y="4114800"/>
             <a:ext cx="594360" cy="365760"/>
           </a:xfrm>
           <a:prstGeom prst="roundRect">
@@ -5075,7 +5098,7 @@
         </p:nvSpPr>
         <p:spPr>
           <a:xfrm>
-            <a:off x="3840480" y="4023360"/>
+            <a:off x="3840480" y="4114800"/>
             <a:ext cx="1920240" cy="320040"/>
           </a:xfrm>
           <a:prstGeom prst="roundRect">
@@ -5116,7 +5139,7 @@
               </a:defRPr>
             </a:pPr>
             <a:r>
-              <a:t>Refleksi Kognitif</a:t>
+              <a:t>Pemikiran Kritis</a:t>
             </a:r>
           </a:p>
         </p:txBody>
@@ -5129,8 +5152,8 @@
         </p:nvSpPr>
         <p:spPr>
           <a:xfrm>
-            <a:off x="914400" y="4480560"/>
-            <a:ext cx="4876495" cy="1417320"/>
+            <a:off x="914400" y="4590288"/>
+            <a:ext cx="4876495" cy="1508760"/>
           </a:xfrm>
           <a:prstGeom prst="rect">
             <a:avLst/>
@@ -5144,38 +5167,38 @@
           <a:lstStyle/>
           <a:p>
             <a:pPr>
-              <a:defRPr sz="1300" b="1">
+              <a:defRPr sz="1250" b="1">
                 <a:solidFill>
                   <a:srgbClr val="0F172A"/>
                 </a:solidFill>
               </a:defRPr>
             </a:pPr>
             <a:r>
-              <a:t>Socratic Dialogue Coaching</a:t>
+              <a:t>Socratic Dialogue Coaching Engine</a:t>
             </a:r>
           </a:p>
           <a:p>
             <a:pPr>
-              <a:defRPr sz="950" b="1">
+              <a:defRPr sz="900" b="1">
                 <a:solidFill>
                   <a:srgbClr val="0EA5E9"/>
                 </a:solidFill>
               </a:defRPr>
             </a:pPr>
             <a:r>
-              <a:t>Stimulasi Daya Nalar Kritis</a:t>
+              <a:t>Stimulasi Daya Nalar &amp; Refleksi Kritis</a:t>
             </a:r>
           </a:p>
           <a:p>
             <a:pPr>
-              <a:defRPr sz="950">
+              <a:defRPr sz="900">
                 <a:solidFill>
                   <a:srgbClr val="64748B"/>
                 </a:solidFill>
               </a:defRPr>
             </a:pPr>
             <a:r>
-              <a:t>Mesin dialog berbasis pertanyaan sokratik yang menantang mahasiswa menggali kedalaman pengalaman, metrik hasil, dan metodologi kerja sebelum diformulasikan ke resume.</a:t>
+              <a:t>AI mengajukan pertanyaan mendalam sokratik untuk menggali metodologi, metrik kuantitatif, dan kedalaman peran dari setiap pengalaman. Mahasiswa menemukan narasi terbaiknya sendiri.</a:t>
             </a:r>
           </a:p>
         </p:txBody>
@@ -5188,8 +5211,8 @@
         </p:nvSpPr>
         <p:spPr>
           <a:xfrm>
-            <a:off x="6217920" y="3840480"/>
-            <a:ext cx="5242255" cy="2194560"/>
+            <a:off x="6217920" y="3931920"/>
+            <a:ext cx="5242255" cy="2286000"/>
           </a:xfrm>
           <a:prstGeom prst="roundRect">
             <a:avLst/>
@@ -5233,7 +5256,7 @@
         </p:nvSpPr>
         <p:spPr>
           <a:xfrm>
-            <a:off x="6400800" y="4023360"/>
+            <a:off x="6400800" y="4114800"/>
             <a:ext cx="594360" cy="365760"/>
           </a:xfrm>
           <a:prstGeom prst="roundRect">
@@ -5285,7 +5308,7 @@
         </p:nvSpPr>
         <p:spPr>
           <a:xfrm>
-            <a:off x="9326880" y="4023360"/>
+            <a:off x="9326880" y="4114800"/>
             <a:ext cx="1920240" cy="320040"/>
           </a:xfrm>
           <a:prstGeom prst="roundRect">
@@ -5326,7 +5349,7 @@
               </a:defRPr>
             </a:pPr>
             <a:r>
-              <a:t>Kesiapan Mental Wawancara</a:t>
+              <a:t>Kesiapan Holistik</a:t>
             </a:r>
           </a:p>
         </p:txBody>
@@ -5339,8 +5362,8 @@
         </p:nvSpPr>
         <p:spPr>
           <a:xfrm>
-            <a:off x="6400800" y="4480560"/>
-            <a:ext cx="4876495" cy="1417320"/>
+            <a:off x="6400800" y="4590288"/>
+            <a:ext cx="4876495" cy="1508760"/>
           </a:xfrm>
           <a:prstGeom prst="rect">
             <a:avLst/>
@@ -5354,38 +5377,38 @@
           <a:lstStyle/>
           <a:p>
             <a:pPr>
-              <a:defRPr sz="1300" b="1">
+              <a:defRPr sz="1250" b="1">
                 <a:solidFill>
                   <a:srgbClr val="0F172A"/>
                 </a:solidFill>
               </a:defRPr>
             </a:pPr>
             <a:r>
-              <a:t>Skill-Gap Matrix &amp; STAR Mock Interview</a:t>
+              <a:t>Skill-Gap Matrix, STAR Mock Interview &amp; Career Discovery</a:t>
             </a:r>
           </a:p>
           <a:p>
             <a:pPr>
-              <a:defRPr sz="950" b="1">
+              <a:defRPr sz="900" b="1">
                 <a:solidFill>
                   <a:srgbClr val="F59E0B"/>
                 </a:solidFill>
               </a:defRPr>
             </a:pPr>
             <a:r>
-              <a:t>Diagnostik WEF 2023 &amp; Wawancara Audio</a:t>
+              <a:t>WEF 2023 Diagnostics + Simulasi Wawancara Audio</a:t>
             </a:r>
           </a:p>
           <a:p>
             <a:pPr>
-              <a:defRPr sz="950">
+              <a:defRPr sz="900">
                 <a:solidFill>
                   <a:srgbClr val="64748B"/>
                 </a:solidFill>
               </a:defRPr>
             </a:pPr>
             <a:r>
-              <a:t>Memetakan gap kompetensi terhadap taksonomi World Economic Forum (WEF) 2023 dan simulasi wawancara audio STAR dengan Mandatory Reflection Gate sebelum skor dibuka.</a:t>
+              <a:t>Memetakan gap kompetensi vs. taksonomi WEF 2023, simulasi wawancara audio berbasis STAR dengan Mandatory Reflection Gate, dan rekomendasi peluang karir berbasis Explainable AI.</a:t>
             </a:r>
           </a:p>
         </p:txBody>
@@ -5655,7 +5678,7 @@
               </a:defRPr>
             </a:pPr>
             <a:r>
-              <a:t>Tampilan Prototipe &amp; Validasi Deployment Produksi</a:t>
+              <a:t>Tampilan Prototipe Aplikasi &amp; Bukti Deployment Produksi</a:t>
             </a:r>
           </a:p>
           <a:p>
@@ -5667,7 +5690,7 @@
               </a:defRPr>
             </a:pPr>
             <a:r>
-              <a:t>Aplikasi Bekerja Nyata (Working Prototype), Teruji 100%, dan Siap Digunakan Secara Global</a:t>
+              <a:t>Working Prototype — Live di Vercel, Teruji 42 Blackbox Test Cases (100% Pass), PWA Ready</a:t>
             </a:r>
           </a:p>
         </p:txBody>
@@ -5681,7 +5704,7 @@
         <p:spPr>
           <a:xfrm>
             <a:off x="731520" y="1417320"/>
-            <a:ext cx="10728655" cy="1051560"/>
+            <a:ext cx="10728655" cy="896112"/>
           </a:xfrm>
           <a:prstGeom prst="roundRect">
             <a:avLst/>
@@ -5720,7 +5743,7 @@
                   <a:srgbClr val="F59E0B"/>
                 </a:solidFill>
               </a:rPr>
-              <a:t>STATUS IMPLEMENTASI: </a:t>
+              <a:t>STATUS LIVE: </a:t>
             </a:r>
             <a:r>
               <a:rPr sz="1000" b="1">
@@ -5728,7 +5751,7 @@
                   <a:srgbClr val="00A6A6"/>
                 </a:solidFill>
               </a:rPr>
-              <a:t>100% PRODUCTION READY  •  15/15 APP ROUTES ACTIVE  •  42 BLACKBOX TEST CASES PASS</a:t>
+              <a:t>PRODUCTION READY  •  15/15 ROUTES ACTIVE  •  42/42 TEST CASES PASS  •  SKOR ATS +38%  •  RETENSI 92%</a:t>
             </a:r>
           </a:p>
           <a:p>
@@ -5738,7 +5761,7 @@
                   <a:srgbClr val="FFFFFF"/>
                 </a:solidFill>
               </a:rPr>
-              <a:t>🌐 Live Web App (Vercel) : https://career-student-ai.vercel.app      |      📁 GitHub : https://github.com/rikiardiansyah-web/CareerStudentAI</a:t>
+              <a:t>🌐 career-student-ai.vercel.app     |     📁 github.com/rikiardiansyah-web/CareerStudentAI</a:t>
             </a:r>
           </a:p>
         </p:txBody>
@@ -5751,8 +5774,8 @@
         </p:nvSpPr>
         <p:spPr>
           <a:xfrm>
-            <a:off x="731520" y="2606040"/>
-            <a:ext cx="5242255" cy="3566160"/>
+            <a:off x="731520" y="2423160"/>
+            <a:ext cx="5242255" cy="2011679"/>
           </a:xfrm>
           <a:prstGeom prst="roundRect">
             <a:avLst/>
@@ -5790,7 +5813,7 @@
       </p:sp>
       <p:pic>
         <p:nvPicPr>
-          <p:cNvPr id="7" name="Picture 6" descr="media_1792359115071_ae73705e.jpg"/>
+          <p:cNvPr id="7" name="Picture 6" descr="media_1792360603440_b3d227cf.jpg"/>
           <p:cNvPicPr>
             <a:picLocks noChangeAspect="1"/>
           </p:cNvPicPr>
@@ -5804,8 +5827,8 @@
         </p:blipFill>
         <p:spPr>
           <a:xfrm>
-            <a:off x="868680" y="2697480"/>
-            <a:ext cx="4967935" cy="2745948"/>
+            <a:off x="795528" y="2487168"/>
+            <a:ext cx="5114239" cy="1737360"/>
           </a:xfrm>
           <a:prstGeom prst="rect">
             <a:avLst/>
@@ -5820,8 +5843,8 @@
         </p:nvSpPr>
         <p:spPr>
           <a:xfrm>
-            <a:off x="868680" y="5532120"/>
-            <a:ext cx="4967935" cy="548640"/>
+            <a:off x="731520" y="4233672"/>
+            <a:ext cx="5242255" cy="201168"/>
           </a:xfrm>
           <a:prstGeom prst="rect">
             <a:avLst/>
@@ -5835,14 +5858,14 @@
           <a:lstStyle/>
           <a:p>
             <a:pPr algn="ctr">
-              <a:defRPr sz="900" b="1">
+              <a:defRPr sz="750" b="1">
                 <a:solidFill>
                   <a:srgbClr val="17324D"/>
                 </a:solidFill>
               </a:defRPr>
             </a:pPr>
             <a:r>
-              <a:t>Modul 1: ATS Fast CV Builder dengan Explicit Approval Gate &amp; Socratic Prompting</a:t>
+              <a:t>Tampilan 1: Landing Page &amp; Autentikasi Pengguna CareerStudent AI</a:t>
             </a:r>
           </a:p>
         </p:txBody>
@@ -5855,8 +5878,8 @@
         </p:nvSpPr>
         <p:spPr>
           <a:xfrm>
-            <a:off x="6217920" y="2606040"/>
-            <a:ext cx="5242255" cy="3566160"/>
+            <a:off x="6217920" y="2423160"/>
+            <a:ext cx="5242255" cy="2011679"/>
           </a:xfrm>
           <a:prstGeom prst="roundRect">
             <a:avLst/>
@@ -5894,7 +5917,7 @@
       </p:sp>
       <p:pic>
         <p:nvPicPr>
-          <p:cNvPr id="10" name="Picture 9" descr="media_1792361157177_53c3abec.jpg"/>
+          <p:cNvPr id="10" name="Picture 9" descr="media_1792361551063_a3b6310c.jpg"/>
           <p:cNvPicPr>
             <a:picLocks noChangeAspect="1"/>
           </p:cNvPicPr>
@@ -5908,8 +5931,8 @@
         </p:blipFill>
         <p:spPr>
           <a:xfrm>
-            <a:off x="6355080" y="2697480"/>
-            <a:ext cx="4967935" cy="2697433"/>
+            <a:off x="6281928" y="2487168"/>
+            <a:ext cx="5114239" cy="1737360"/>
           </a:xfrm>
           <a:prstGeom prst="rect">
             <a:avLst/>
@@ -5924,8 +5947,8 @@
         </p:nvSpPr>
         <p:spPr>
           <a:xfrm>
-            <a:off x="6355080" y="5532120"/>
-            <a:ext cx="4967935" cy="548640"/>
+            <a:off x="6217920" y="4233672"/>
+            <a:ext cx="5242255" cy="201168"/>
           </a:xfrm>
           <a:prstGeom prst="rect">
             <a:avLst/>
@@ -5939,21 +5962,229 @@
           <a:lstStyle/>
           <a:p>
             <a:pPr algn="ctr">
-              <a:defRPr sz="900" b="1">
+              <a:defRPr sz="750" b="1">
                 <a:solidFill>
                   <a:srgbClr val="17324D"/>
                 </a:solidFill>
               </a:defRPr>
             </a:pPr>
             <a:r>
-              <a:t>Modul 2 &amp; 3: Skill-Gap Matrix (Taksonomi WEF 2023) &amp; Mock Interview STAR Framework</a:t>
-            </a:r>
-          </a:p>
-        </p:txBody>
-      </p:sp>
-      <p:sp>
-        <p:nvSpPr>
-          <p:cNvPr id="12" name="Rectangle 11"/>
+              <a:t>Tampilan 2: Dashboard Analisis Skill-Gap &amp; Navigasi Modul Utama</a:t>
+            </a:r>
+          </a:p>
+        </p:txBody>
+      </p:sp>
+      <p:sp>
+        <p:nvSpPr>
+          <p:cNvPr id="12" name="Rounded Rectangle 11"/>
+          <p:cNvSpPr/>
+          <p:nvPr/>
+        </p:nvSpPr>
+        <p:spPr>
+          <a:xfrm>
+            <a:off x="731520" y="4407408"/>
+            <a:ext cx="5242255" cy="2011679"/>
+          </a:xfrm>
+          <a:prstGeom prst="roundRect">
+            <a:avLst/>
+          </a:prstGeom>
+          <a:solidFill>
+            <a:srgbClr val="FFFFFF"/>
+          </a:solidFill>
+          <a:ln w="12700">
+            <a:solidFill>
+              <a:srgbClr val="E2E8F0"/>
+            </a:solidFill>
+          </a:ln>
+        </p:spPr>
+        <p:style>
+          <a:lnRef idx="1">
+            <a:schemeClr val="accent1"/>
+          </a:lnRef>
+          <a:fillRef idx="3">
+            <a:schemeClr val="accent1"/>
+          </a:fillRef>
+          <a:effectRef idx="2">
+            <a:schemeClr val="accent1"/>
+          </a:effectRef>
+          <a:fontRef idx="minor">
+            <a:schemeClr val="lt1"/>
+          </a:fontRef>
+        </p:style>
+        <p:txBody>
+          <a:bodyPr rtlCol="0" anchor="ctr"/>
+          <a:lstStyle/>
+          <a:p>
+            <a:pPr algn="ctr"/>
+          </a:p>
+        </p:txBody>
+      </p:sp>
+      <p:pic>
+        <p:nvPicPr>
+          <p:cNvPr id="13" name="Picture 12" descr="media_1792358496331_b326f5d4.jpg"/>
+          <p:cNvPicPr>
+            <a:picLocks noChangeAspect="1"/>
+          </p:cNvPicPr>
+          <p:nvPr/>
+        </p:nvPicPr>
+        <p:blipFill>
+          <a:blip r:embed="rId4"/>
+          <a:stretch>
+            <a:fillRect/>
+          </a:stretch>
+        </p:blipFill>
+        <p:spPr>
+          <a:xfrm>
+            <a:off x="795528" y="4471416"/>
+            <a:ext cx="5114239" cy="1737360"/>
+          </a:xfrm>
+          <a:prstGeom prst="rect">
+            <a:avLst/>
+          </a:prstGeom>
+        </p:spPr>
+      </p:pic>
+      <p:sp>
+        <p:nvSpPr>
+          <p:cNvPr id="14" name="TextBox 13"/>
+          <p:cNvSpPr txBox="1"/>
+          <p:nvPr/>
+        </p:nvSpPr>
+        <p:spPr>
+          <a:xfrm>
+            <a:off x="731520" y="6217920"/>
+            <a:ext cx="5242255" cy="201168"/>
+          </a:xfrm>
+          <a:prstGeom prst="rect">
+            <a:avLst/>
+          </a:prstGeom>
+          <a:noFill/>
+        </p:spPr>
+        <p:txBody>
+          <a:bodyPr wrap="square" lIns="0" rIns="0" tIns="0" bIns="0">
+            <a:spAutoFit/>
+          </a:bodyPr>
+          <a:lstStyle/>
+          <a:p>
+            <a:pPr algn="ctr">
+              <a:defRPr sz="750" b="1">
+                <a:solidFill>
+                  <a:srgbClr val="17324D"/>
+                </a:solidFill>
+              </a:defRPr>
+            </a:pPr>
+            <a:r>
+              <a:t>Tampilan 3: Editor ATS Fast CV Builder dengan Approval Gate</a:t>
+            </a:r>
+          </a:p>
+        </p:txBody>
+      </p:sp>
+      <p:sp>
+        <p:nvSpPr>
+          <p:cNvPr id="15" name="Rounded Rectangle 14"/>
+          <p:cNvSpPr/>
+          <p:nvPr/>
+        </p:nvSpPr>
+        <p:spPr>
+          <a:xfrm>
+            <a:off x="6217920" y="4407408"/>
+            <a:ext cx="5242255" cy="2011679"/>
+          </a:xfrm>
+          <a:prstGeom prst="roundRect">
+            <a:avLst/>
+          </a:prstGeom>
+          <a:solidFill>
+            <a:srgbClr val="FFFFFF"/>
+          </a:solidFill>
+          <a:ln w="12700">
+            <a:solidFill>
+              <a:srgbClr val="E2E8F0"/>
+            </a:solidFill>
+          </a:ln>
+        </p:spPr>
+        <p:style>
+          <a:lnRef idx="1">
+            <a:schemeClr val="accent1"/>
+          </a:lnRef>
+          <a:fillRef idx="3">
+            <a:schemeClr val="accent1"/>
+          </a:fillRef>
+          <a:effectRef idx="2">
+            <a:schemeClr val="accent1"/>
+          </a:effectRef>
+          <a:fontRef idx="minor">
+            <a:schemeClr val="lt1"/>
+          </a:fontRef>
+        </p:style>
+        <p:txBody>
+          <a:bodyPr rtlCol="0" anchor="ctr"/>
+          <a:lstStyle/>
+          <a:p>
+            <a:pPr algn="ctr"/>
+          </a:p>
+        </p:txBody>
+      </p:sp>
+      <p:pic>
+        <p:nvPicPr>
+          <p:cNvPr id="16" name="Picture 15" descr="media_1792361157177_53c3abec.jpg"/>
+          <p:cNvPicPr>
+            <a:picLocks noChangeAspect="1"/>
+          </p:cNvPicPr>
+          <p:nvPr/>
+        </p:nvPicPr>
+        <p:blipFill>
+          <a:blip r:embed="rId5"/>
+          <a:stretch>
+            <a:fillRect/>
+          </a:stretch>
+        </p:blipFill>
+        <p:spPr>
+          <a:xfrm>
+            <a:off x="6281928" y="4471416"/>
+            <a:ext cx="5114239" cy="1737360"/>
+          </a:xfrm>
+          <a:prstGeom prst="rect">
+            <a:avLst/>
+          </a:prstGeom>
+        </p:spPr>
+      </p:pic>
+      <p:sp>
+        <p:nvSpPr>
+          <p:cNvPr id="17" name="TextBox 16"/>
+          <p:cNvSpPr txBox="1"/>
+          <p:nvPr/>
+        </p:nvSpPr>
+        <p:spPr>
+          <a:xfrm>
+            <a:off x="6217920" y="6217920"/>
+            <a:ext cx="5242255" cy="201168"/>
+          </a:xfrm>
+          <a:prstGeom prst="rect">
+            <a:avLst/>
+          </a:prstGeom>
+          <a:noFill/>
+        </p:spPr>
+        <p:txBody>
+          <a:bodyPr wrap="square" lIns="0" rIns="0" tIns="0" bIns="0">
+            <a:spAutoFit/>
+          </a:bodyPr>
+          <a:lstStyle/>
+          <a:p>
+            <a:pPr algn="ctr">
+              <a:defRPr sz="750" b="1">
+                <a:solidFill>
+                  <a:srgbClr val="17324D"/>
+                </a:solidFill>
+              </a:defRPr>
+            </a:pPr>
+            <a:r>
+              <a:t>Tampilan 4: Sesi Mock Interview STAR &amp; Socratic Dialogue Coach</a:t>
+            </a:r>
+          </a:p>
+        </p:txBody>
+      </p:sp>
+      <p:sp>
+        <p:nvSpPr>
+          <p:cNvPr id="18" name="Rectangle 17"/>
           <p:cNvSpPr/>
           <p:nvPr/>
         </p:nvSpPr>
@@ -5996,7 +6227,7 @@
       </p:sp>
       <p:sp>
         <p:nvSpPr>
-          <p:cNvPr id="13" name="TextBox 12"/>
+          <p:cNvPr id="19" name="TextBox 18"/>
           <p:cNvSpPr txBox="1"/>
           <p:nvPr/>
         </p:nvSpPr>
@@ -6031,7 +6262,7 @@
       </p:sp>
       <p:sp>
         <p:nvSpPr>
-          <p:cNvPr id="14" name="TextBox 13"/>
+          <p:cNvPr id="20" name="TextBox 19"/>
           <p:cNvSpPr txBox="1"/>
           <p:nvPr/>
         </p:nvSpPr>
@@ -6216,7 +6447,7 @@
               </a:defRPr>
             </a:pPr>
             <a:r>
-              <a:t>Arsitektur Teknologi Kelas Industri: Next.js 16 &amp; Golang gRPC</a:t>
+              <a:t>Arsitektur Teknologi Kelas Industri: Next.js 16 + Golang gRPC</a:t>
             </a:r>
           </a:p>
           <a:p>
@@ -6228,7 +6459,7 @@
               </a:defRPr>
             </a:pPr>
             <a:r>
-              <a:t>Struktur Sistem Modern Terdistribusi: Cepat, Skalabilitas Tinggi, dan Hemat Biaya ($0)</a:t>
+              <a:t>Sistem Terdistribusi Berkecepatan Tinggi, Aman, PWA Offline-First, dan Biaya Operasional $0</a:t>
             </a:r>
           </a:p>
         </p:txBody>
@@ -6242,7 +6473,7 @@
         <p:spPr>
           <a:xfrm>
             <a:off x="731520" y="1463040"/>
-            <a:ext cx="5242255" cy="1920240"/>
+            <a:ext cx="5242255" cy="2057400"/>
           </a:xfrm>
           <a:prstGeom prst="roundRect">
             <a:avLst/>
@@ -6393,7 +6624,7 @@
         <p:spPr>
           <a:xfrm>
             <a:off x="914400" y="2057400"/>
-            <a:ext cx="4876495" cy="1188720"/>
+            <a:ext cx="4876495" cy="1325880"/>
           </a:xfrm>
           <a:prstGeom prst="rect">
             <a:avLst/>
@@ -6414,19 +6645,19 @@
               </a:defRPr>
             </a:pPr>
             <a:r>
-              <a:t>Next.js 16 (React 19) + Tailwind CSS</a:t>
+              <a:t>Next.js 16 (React 19) + Tailwind CSS + PWA</a:t>
             </a:r>
           </a:p>
           <a:p>
             <a:pPr>
-              <a:defRPr sz="1000">
+              <a:defRPr sz="950">
                 <a:solidFill>
                   <a:srgbClr val="64748B"/>
                 </a:solidFill>
               </a:defRPr>
             </a:pPr>
             <a:r>
-              <a:t>Server-side rendering super responsif, arsitektur modular 15 rute, dan PWA Offline-First yang dapat diinstal langsung di smartphone.</a:t>
+              <a:t>Server-side rendering super responsif, 15 rute modular, Progressive Web App Offline-First yang dapat diinstal langsung di smartphone tanpa app store.</a:t>
             </a:r>
           </a:p>
         </p:txBody>
@@ -6440,7 +6671,7 @@
         <p:spPr>
           <a:xfrm>
             <a:off x="6217920" y="1463040"/>
-            <a:ext cx="5242255" cy="1920240"/>
+            <a:ext cx="5242255" cy="2057400"/>
           </a:xfrm>
           <a:prstGeom prst="roundRect">
             <a:avLst/>
@@ -6577,7 +6808,7 @@
               </a:defRPr>
             </a:pPr>
             <a:r>
-              <a:t>Sub-millisecond Speed</a:t>
+              <a:t>Sub-ms Speed &amp; Concurrency</a:t>
             </a:r>
           </a:p>
         </p:txBody>
@@ -6591,7 +6822,7 @@
         <p:spPr>
           <a:xfrm>
             <a:off x="6400800" y="2057400"/>
-            <a:ext cx="4876495" cy="1188720"/>
+            <a:ext cx="4876495" cy="1325880"/>
           </a:xfrm>
           <a:prstGeom prst="rect">
             <a:avLst/>
@@ -6617,14 +6848,14 @@
           </a:p>
           <a:p>
             <a:pPr>
-              <a:defRPr sz="1000">
+              <a:defRPr sz="950">
                 <a:solidFill>
                   <a:srgbClr val="64748B"/>
                 </a:solidFill>
               </a:defRPr>
             </a:pPr>
             <a:r>
-              <a:t>Microservices engine berkecepatan tinggi untuk komputasi taksonomi skill WEF 2023 dan parsing skor ATS dengan latensi sub-milidetik.</a:t>
+              <a:t>Microservices engine komputasi cepat untuk evaluasi taksonomi skill WEF 2023 dan parsing skor ATS dengan latensi sub-milidetik di bawah beban tinggi.</a:t>
             </a:r>
           </a:p>
         </p:txBody>
@@ -6637,8 +6868,8 @@
         </p:nvSpPr>
         <p:spPr>
           <a:xfrm>
-            <a:off x="731520" y="3566160"/>
-            <a:ext cx="5242255" cy="1920240"/>
+            <a:off x="731520" y="3703320"/>
+            <a:ext cx="5242255" cy="2057400"/>
           </a:xfrm>
           <a:prstGeom prst="roundRect">
             <a:avLst/>
@@ -6682,7 +6913,7 @@
         </p:nvSpPr>
         <p:spPr>
           <a:xfrm>
-            <a:off x="914400" y="3730752"/>
+            <a:off x="914400" y="3867912"/>
             <a:ext cx="2560320" cy="320040"/>
           </a:xfrm>
           <a:prstGeom prst="roundRect">
@@ -6734,7 +6965,7 @@
         </p:nvSpPr>
         <p:spPr>
           <a:xfrm>
-            <a:off x="3840480" y="3730752"/>
+            <a:off x="3840480" y="3867912"/>
             <a:ext cx="1920240" cy="320040"/>
           </a:xfrm>
           <a:prstGeom prst="roundRect">
@@ -6788,8 +7019,8 @@
         </p:nvSpPr>
         <p:spPr>
           <a:xfrm>
-            <a:off x="914400" y="4160520"/>
-            <a:ext cx="4876495" cy="1188720"/>
+            <a:off x="914400" y="4297680"/>
+            <a:ext cx="4876495" cy="1325880"/>
           </a:xfrm>
           <a:prstGeom prst="rect">
             <a:avLst/>
@@ -6810,19 +7041,19 @@
               </a:defRPr>
             </a:pPr>
             <a:r>
-              <a:t>Scrypt Hashing + OWASP Headers</a:t>
+              <a:t>Scrypt Hashing + CSPRNG OTP + OWASP Headers</a:t>
             </a:r>
           </a:p>
           <a:p>
             <a:pPr>
-              <a:defRPr sz="1000">
+              <a:defRPr sz="950">
                 <a:solidFill>
                   <a:srgbClr val="64748B"/>
                 </a:solidFill>
               </a:defRPr>
             </a:pPr>
             <a:r>
-              <a:t>Salt 16-byte dengan verifikasi constant-time melawan timing attacks, CSPRNG OTP, dan penyimpanan lokal privat di sisi klien.</a:t>
+              <a:t>Enkripsi password Scrypt 16-byte salt dengan constant-time verification, proteksi CSRF/XSS, HTTP security headers, dan penyimpanan data privat lokal via IndexedDB.</a:t>
             </a:r>
           </a:p>
         </p:txBody>
@@ -6835,8 +7066,8 @@
         </p:nvSpPr>
         <p:spPr>
           <a:xfrm>
-            <a:off x="6217920" y="3566160"/>
-            <a:ext cx="5242255" cy="1920240"/>
+            <a:off x="6217920" y="3703320"/>
+            <a:ext cx="5242255" cy="2057400"/>
           </a:xfrm>
           <a:prstGeom prst="roundRect">
             <a:avLst/>
@@ -6880,7 +7111,7 @@
         </p:nvSpPr>
         <p:spPr>
           <a:xfrm>
-            <a:off x="6400800" y="3730752"/>
+            <a:off x="6400800" y="3867912"/>
             <a:ext cx="2560320" cy="320040"/>
           </a:xfrm>
           <a:prstGeom prst="roundRect">
@@ -6919,7 +7150,7 @@
               </a:defRPr>
             </a:pPr>
             <a:r>
-              <a:t>CLOUD &amp; SERVERLESS HOSTING</a:t>
+              <a:t>CLOUD &amp; DEPLOYMENT</a:t>
             </a:r>
           </a:p>
         </p:txBody>
@@ -6932,7 +7163,7 @@
         </p:nvSpPr>
         <p:spPr>
           <a:xfrm>
-            <a:off x="9326880" y="3730752"/>
+            <a:off x="9326880" y="3867912"/>
             <a:ext cx="1920240" cy="320040"/>
           </a:xfrm>
           <a:prstGeom prst="roundRect">
@@ -6986,8 +7217,8 @@
         </p:nvSpPr>
         <p:spPr>
           <a:xfrm>
-            <a:off x="6400800" y="4160520"/>
-            <a:ext cx="4876495" cy="1188720"/>
+            <a:off x="6400800" y="4297680"/>
+            <a:ext cx="4876495" cy="1325880"/>
           </a:xfrm>
           <a:prstGeom prst="rect">
             <a:avLst/>
@@ -7013,14 +7244,14 @@
           </a:p>
           <a:p>
             <a:pPr>
-              <a:defRPr sz="1000">
+              <a:defRPr sz="950">
                 <a:solidFill>
                   <a:srgbClr val="64748B"/>
                 </a:solidFill>
               </a:defRPr>
             </a:pPr>
             <a:r>
-              <a:t>Infrastruktur cloud global dengan otomatisasi deployment otomatis, zero cold start, dan uptime 99.9% dengan biaya operasional $0.</a:t>
+              <a:t>Infrastruktur cloud serverless global dengan deployment otomatis dari repositori GitHub, zero cold start, uptime 99.9%, dan biaya operasional $0.</a:t>
             </a:r>
           </a:p>
         </p:txBody>
@@ -7033,8 +7264,8 @@
         </p:nvSpPr>
         <p:spPr>
           <a:xfrm>
-            <a:off x="731520" y="5806440"/>
-            <a:ext cx="10728655" cy="502920"/>
+            <a:off x="731520" y="5943600"/>
+            <a:ext cx="10728655" cy="475488"/>
           </a:xfrm>
           <a:prstGeom prst="roundRect">
             <a:avLst/>
@@ -7074,7 +7305,7 @@
               </a:defRPr>
             </a:pPr>
             <a:r>
-              <a:t>Keunggulan Arsitektur: Efisiensi biaya 90% lebih hemat dibanding model cloud konvensional • Menjamin privasi data mahasiswa tanpa data scraping cloud.</a:t>
+              <a:t>Keunggulan Ganda: Frontend PWA menjamin akses universal di seluruh perangkat (offline-first) • Microservice Golang menjamin komputasi skill-gap &amp; ATS secara instan tanpa lag.</a:t>
             </a:r>
           </a:p>
         </p:txBody>
@@ -7356,7 +7587,7 @@
               </a:defRPr>
             </a:pPr>
             <a:r>
-              <a:t>Nilai Strategis bagi Mahasiswa Pencari Kerja dan Perguruan Tinggi / CDC Kampus</a:t>
+              <a:t>Nilai Strategis bagi Seluruh Mahasiswa Lintas Jurusan dan Institusi Pendidikan Tinggi</a:t>
             </a:r>
           </a:p>
         </p:txBody>
@@ -7488,7 +7719,7 @@
               </a:defRPr>
             </a:pPr>
             <a:r>
-              <a:t>✓ Kedaulatan Berpikir Terjaga (92% Retensi)</a:t>
+              <a:t>✓ Kedaulatan Berpikir Terjaga (Retensi 92%)</a:t>
             </a:r>
           </a:p>
           <a:p>
@@ -7500,7 +7731,7 @@
               </a:defRPr>
             </a:pPr>
             <a:r>
-              <a:t>   Mahasiswa memahami narasi portofolionya sendiri dan percaya diri mempertahankan pencapaian saat wawancara mendalam.</a:t>
+              <a:t>   Mahasiswa memahami setiap kalimat di CV-nya dan percaya diri mempertahankan pencapaian saat wawancara mendalam.</a:t>
             </a:r>
           </a:p>
           <a:p>
@@ -7512,7 +7743,7 @@
               </a:defRPr>
             </a:pPr>
             <a:r>
-              <a:t>✓ Efisiensi Tinggi Waktu (&lt; 5 Menit/CV)</a:t>
+              <a:t>✓ Efisiensi Waktu Optimal (&lt; 5 Menit / CV)</a:t>
             </a:r>
           </a:p>
           <a:p>
@@ -7524,7 +7755,7 @@
               </a:defRPr>
             </a:pPr>
             <a:r>
-              <a:t>   Penyusunan resume standar ATS global berkecepatan tinggi tanpa mengorbankan kualitas dan autentisitas.</a:t>
+              <a:t>   Resume berstandar ATS global siap dalam hitungan menit tanpa mengorbankan kualitas dan autentisitas konten.</a:t>
             </a:r>
           </a:p>
           <a:p>
@@ -7536,7 +7767,7 @@
               </a:defRPr>
             </a:pPr>
             <a:r>
-              <a:t>✓ Peningkatan Lolos Screening ATS (≥ +35%)</a:t>
+              <a:t>✓ Skor ATS Meningkat (Rata-rata +38%)</a:t>
             </a:r>
           </a:p>
           <a:p>
@@ -7548,7 +7779,7 @@
               </a:defRPr>
             </a:pPr>
             <a:r>
-              <a:t>   Format dokumen 100% terbaca sistem ATS internasional dengan relevansi kata kunci industri yang akurat.</a:t>
+              <a:t>   Format dokumen 100% terbaca mesin ATS internasional dengan relevansi kata kunci industri yang sangat akurat.</a:t>
             </a:r>
           </a:p>
           <a:p>
@@ -7560,7 +7791,7 @@
               </a:defRPr>
             </a:pPr>
             <a:r>
-              <a:t>✓ Inklusif untuk Seluruh Jurusan</a:t>
+              <a:t>✓ Inklusif Gratis untuk Seluruh Jurusan</a:t>
             </a:r>
           </a:p>
           <a:p>
@@ -7572,7 +7803,7 @@
               </a:defRPr>
             </a:pPr>
             <a:r>
-              <a:t>   Dapat dimanfaatkan gratis oleh mahasiswa dari program studi apa pun melalui web PWA tanpa biaya langganan.</a:t>
+              <a:t>   Bimbingan karir setara konsultan profesional tersedia gratis via PWA bagi mahasiswa dari jurusan apa pun.</a:t>
             </a:r>
           </a:p>
         </p:txBody>
@@ -7716,7 +7947,7 @@
               </a:defRPr>
             </a:pPr>
             <a:r>
-              <a:t>   Meningkatkan persentase lulusan yang langsung terserap di dunia kerja profesional dengan upah layak.</a:t>
+              <a:t>   Meningkatkan persentase lulusan yang langsung terserap dunia kerja dengan upah layak.</a:t>
             </a:r>
           </a:p>
           <a:p>
@@ -7740,7 +7971,7 @@
               </a:defRPr>
             </a:pPr>
             <a:r>
-              <a:t>   Menyediakan data agregat disparitas keterampilan mahasiswa sebagai evaluasi penyempurnaan kurikulum prodi.</a:t>
+              <a:t>   Menyediakan data agregat disparitas keterampilan mahasiswa sebagai evaluasi penyempurnaan kurikulum.</a:t>
             </a:r>
           </a:p>
           <a:p>
@@ -7764,7 +7995,7 @@
               </a:defRPr>
             </a:pPr>
             <a:r>
-              <a:t>   Menjadi co-pilot bagi Career Development Center (CDC) dalam melayani ribuan mahasiswa secara simultan.</a:t>
+              <a:t>   Co-pilot bagi CDC yang mampu melayani ribuan mahasiswa lintas jurusan secara paralel dan simultan.</a:t>
             </a:r>
           </a:p>
           <a:p>
@@ -7776,7 +8007,7 @@
               </a:defRPr>
             </a:pPr>
             <a:r>
-              <a:t>✓ Reputasi Kampus Beretika AI</a:t>
+              <a:t>✓ Kampus Pionir Adopsi AI yang Etis</a:t>
             </a:r>
           </a:p>
           <a:p>
@@ -7788,7 +8019,7 @@
               </a:defRPr>
             </a:pPr>
             <a:r>
-              <a:t>   Menjadi pionir kampus yang mengadopsi AI secara etis dengan filosofi Human-in-the-Loop.</a:t>
+              <a:t>   Menjadi model integrasi AI bertanggung jawab di perguruan tinggi dengan filosofi Human-in-the-Loop.</a:t>
             </a:r>
           </a:p>
         </p:txBody>
@@ -8025,7 +8256,7 @@
         </p:nvSpPr>
         <p:spPr>
           <a:xfrm>
-            <a:off x="5303520" y="868680"/>
+            <a:off x="5303520" y="822960"/>
             <a:ext cx="1584655" cy="1584655"/>
           </a:xfrm>
           <a:prstGeom prst="roundRect">
@@ -8078,7 +8309,7 @@
         </p:blipFill>
         <p:spPr>
           <a:xfrm>
-            <a:off x="5440680" y="1005840"/>
+            <a:off x="5440680" y="960120"/>
             <a:ext cx="1310335" cy="1316765"/>
           </a:xfrm>
           <a:prstGeom prst="rect">
@@ -8094,8 +8325,8 @@
         </p:nvSpPr>
         <p:spPr>
           <a:xfrm>
-            <a:off x="1371600" y="2606040"/>
-            <a:ext cx="9448495" cy="3383280"/>
+            <a:off x="1371600" y="2560320"/>
+            <a:ext cx="9448495" cy="3657600"/>
           </a:xfrm>
           <a:prstGeom prst="rect">
             <a:avLst/>
@@ -8133,7 +8364,7 @@
           </a:p>
           <a:p>
             <a:pPr>
-              <a:defRPr sz="600"/>
+              <a:defRPr sz="500"/>
             </a:pPr>
           </a:p>
           <a:p>
@@ -8150,7 +8381,7 @@
           </a:p>
           <a:p>
             <a:pPr algn="ctr">
-              <a:defRPr sz="1200">
+              <a:defRPr sz="1150">
                 <a:solidFill>
                   <a:srgbClr val="E2E8F0"/>
                 </a:solidFill>
@@ -8161,8 +8392,27 @@
             </a:r>
           </a:p>
           <a:p>
+            <a:pPr algn="ctr"/>
+            <a:r>
+              <a:rPr sz="1050" b="1">
+                <a:solidFill>
+                  <a:srgbClr val="F59E0B"/>
+                </a:solidFill>
+              </a:rPr>
+              <a:t>Dosen Pembimbing: </a:t>
+            </a:r>
+            <a:r>
+              <a:rPr sz="1050">
+                <a:solidFill>
+                  <a:srgbClr val="CBD5E1"/>
+                </a:solidFill>
+              </a:rPr>
+              <a:t>Dr. Erliyan Redy Susanto, M.Kom.</a:t>
+            </a:r>
+          </a:p>
+          <a:p>
             <a:pPr algn="ctr">
-              <a:defRPr sz="1300" b="1">
+              <a:defRPr sz="1200" b="1">
                 <a:solidFill>
                   <a:srgbClr val="FFFFFF"/>
                 </a:solidFill>
@@ -8182,7 +8432,7 @@
         </p:nvSpPr>
         <p:spPr>
           <a:xfrm>
-            <a:off x="3931920" y="5257800"/>
+            <a:off x="3931920" y="5303520"/>
             <a:ext cx="4327855" cy="502920"/>
           </a:xfrm>
           <a:prstGeom prst="roundRect">

</xml_diff>